<commit_message>
Retitle to AI Automations Expert; real metrics (90-120min run, 2000+/day, Slack, regex-first CV); AI-only-where-needed framing
</commit_message>
<xml_diff>
--- a/deck/AI-Recruiting-Automation-Portfolio.pptx
+++ b/deck/AI-Recruiting-Automation-Portfolio.pptx
@@ -1620,7 +1620,7 @@
                 <a:ea typeface="Consolas" pitchFamily="34" charset="-122"/>
                 <a:cs typeface="Consolas" pitchFamily="34" charset="-120"/>
               </a:rPr>
-              <a:t>CASE STUDY · AUTOMATION ENGINEERING &amp; TECHNICAL WRITING</a:t>
+              <a:t>CASE STUDY · AI AUTOMATION &amp; TECHNICAL DOCUMENTATION</a:t>
             </a:r>
             <a:endParaRPr lang="en-US" sz="1200" dirty="0"/>
           </a:p>
@@ -1697,7 +1697,7 @@
         <p:spPr>
           <a:xfrm>
             <a:off x="640080" y="3886200"/>
-            <a:ext cx="9326880" cy="731520"/>
+            <a:ext cx="9509760" cy="731520"/>
           </a:xfrm>
           <a:prstGeom prst="rect">
             <a:avLst/>
@@ -1721,7 +1721,7 @@
                 <a:ea typeface="Calibri" pitchFamily="34" charset="-122"/>
                 <a:cs typeface="Calibri" pitchFamily="34" charset="-120"/>
               </a:rPr>
-              <a:t>An end-to-end LLM matching engine and a 14-service communications pipeline, designed, built, and documented from scratch, running in production.</a:t>
+              <a:t>A DeepSeek matching engine and a 14-service communications pipeline, designed and built from scratch, running unattended in production.</a:t>
             </a:r>
             <a:endParaRPr lang="en-US" sz="1800" dirty="0"/>
           </a:p>
@@ -1787,7 +1787,7 @@
                 <a:ea typeface="Consolas" pitchFamily="34" charset="-122"/>
                 <a:cs typeface="Consolas" pitchFamily="34" charset="-120"/>
               </a:rPr>
-              <a:t>AI Automation Engineer</a:t>
+              <a:t>AI Automations Expert</a:t>
             </a:r>
             <a:endParaRPr lang="en-US" sz="1100" dirty="0"/>
           </a:p>
@@ -1919,7 +1919,7 @@
                 <a:ea typeface="Consolas" pitchFamily="34" charset="-122"/>
                 <a:cs typeface="Consolas" pitchFamily="34" charset="-120"/>
               </a:rPr>
-              <a:t>LLM Systems · End-to-End</a:t>
+              <a:t>DeepSeek · LLM Workflows</a:t>
             </a:r>
             <a:endParaRPr lang="en-US" sz="1100" dirty="0"/>
           </a:p>
@@ -2742,7 +2742,7 @@
                 <a:ea typeface="Consolas" pitchFamily="34" charset="-122"/>
                 <a:cs typeface="Consolas" pitchFamily="34" charset="-120"/>
               </a:rPr>
-              <a:t>Python · FastAPI · ~3,900 LoC</a:t>
+              <a:t>Python · FastAPI · DeepSeek</a:t>
             </a:r>
             <a:endParaRPr lang="en-US" sz="1250" dirty="0"/>
           </a:p>
@@ -2757,7 +2757,7 @@
         <p:spPr>
           <a:xfrm>
             <a:off x="960120" y="2852928"/>
-            <a:ext cx="4572000" cy="914400"/>
+            <a:ext cx="4572000" cy="1005840"/>
           </a:xfrm>
           <a:prstGeom prst="rect">
             <a:avLst/>
@@ -2781,7 +2781,7 @@
                 <a:ea typeface="Calibri" pitchFamily="34" charset="-122"/>
                 <a:cs typeface="Calibri" pitchFamily="34" charset="-120"/>
               </a:rPr>
-              <a:t>Turns a free-text job description into a ranked shortlist with a written rationale per candidate, through a six-stage funnel.</a:t>
+              <a:t>Ranks candidates with a written rationale each, through a six-stage funnel. A full run takes 90 to 120 min on Railway and posts Slack status to the team.</a:t>
             </a:r>
             <a:endParaRPr lang="en-US" sz="1400" dirty="0"/>
           </a:p>
@@ -2901,7 +2901,7 @@
         <p:spPr>
           <a:xfrm>
             <a:off x="6400800" y="2852928"/>
-            <a:ext cx="4572000" cy="914400"/>
+            <a:ext cx="4572000" cy="1005840"/>
           </a:xfrm>
           <a:prstGeom prst="rect">
             <a:avLst/>
@@ -2925,7 +2925,7 @@
                 <a:ea typeface="Calibri" pitchFamily="34" charset="-122"/>
                 <a:cs typeface="Calibri" pitchFamily="34" charset="-120"/>
               </a:rPr>
-              <a:t>The comms &amp; data pipeline: batched email and WhatsApp outreach, transcript ingestion and scoring, and CV parsing, each isolated.</a:t>
+              <a:t>2,000+ WhatsApp messages and emails a day (Twilio + Postmark), transcript scoring, and a CV parser that finishes in under a minute.</a:t>
             </a:r>
             <a:endParaRPr lang="en-US" sz="1400" dirty="0"/>
           </a:p>
@@ -2966,8 +2966,8 @@
         </p:nvSpPr>
         <p:spPr>
           <a:xfrm>
-            <a:off x="640080" y="4315968"/>
-            <a:ext cx="2514600" cy="640080"/>
+            <a:off x="640080" y="4334256"/>
+            <a:ext cx="2514600" cy="594360"/>
           </a:xfrm>
           <a:prstGeom prst="rect">
             <a:avLst/>
@@ -2983,7 +2983,7 @@
               <a:buNone/>
             </a:pPr>
             <a:r>
-              <a:rPr lang="en-US" sz="3000" b="1" dirty="0">
+              <a:rPr lang="en-US" sz="2600" b="1" dirty="0">
                 <a:solidFill>
                   <a:srgbClr val="5EEAD4"/>
                 </a:solidFill>
@@ -2993,7 +2993,7 @@
               </a:rPr>
               <a:t>40,000</a:t>
             </a:r>
-            <a:endParaRPr lang="en-US" sz="3000" dirty="0"/>
+            <a:endParaRPr lang="en-US" sz="2600" dirty="0"/>
           </a:p>
         </p:txBody>
       </p:sp>
@@ -3005,7 +3005,7 @@
         </p:nvSpPr>
         <p:spPr>
           <a:xfrm>
-            <a:off x="640080" y="5029200"/>
+            <a:off x="640080" y="5010912"/>
             <a:ext cx="2514600" cy="365760"/>
           </a:xfrm>
           <a:prstGeom prst="rect">
@@ -3022,7 +3022,7 @@
               <a:buNone/>
             </a:pPr>
             <a:r>
-              <a:rPr lang="en-US" sz="1250" dirty="0">
+              <a:rPr lang="en-US" sz="1200" dirty="0">
                 <a:solidFill>
                   <a:srgbClr val="9AA7B4"/>
                 </a:solidFill>
@@ -3032,7 +3032,7 @@
               </a:rPr>
               <a:t>rows scanned / run</a:t>
             </a:r>
-            <a:endParaRPr lang="en-US" sz="1250" dirty="0"/>
+            <a:endParaRPr lang="en-US" sz="1200" dirty="0"/>
           </a:p>
         </p:txBody>
       </p:sp>
@@ -3071,8 +3071,8 @@
         </p:nvSpPr>
         <p:spPr>
           <a:xfrm>
-            <a:off x="3364992" y="4315968"/>
-            <a:ext cx="2514600" cy="640080"/>
+            <a:off x="3364992" y="4334256"/>
+            <a:ext cx="2514600" cy="594360"/>
           </a:xfrm>
           <a:prstGeom prst="rect">
             <a:avLst/>
@@ -3088,7 +3088,7 @@
               <a:buNone/>
             </a:pPr>
             <a:r>
-              <a:rPr lang="en-US" sz="3000" b="1" dirty="0">
+              <a:rPr lang="en-US" sz="2600" b="1" dirty="0">
                 <a:solidFill>
                   <a:srgbClr val="5EEAD4"/>
                 </a:solidFill>
@@ -3096,9 +3096,9 @@
                 <a:ea typeface="Georgia" pitchFamily="34" charset="-122"/>
                 <a:cs typeface="Georgia" pitchFamily="34" charset="-120"/>
               </a:rPr>
-              <a:t>~2 hrs</a:t>
-            </a:r>
-            <a:endParaRPr lang="en-US" sz="3000" dirty="0"/>
+              <a:t>90-120 min</a:t>
+            </a:r>
+            <a:endParaRPr lang="en-US" sz="2600" dirty="0"/>
           </a:p>
         </p:txBody>
       </p:sp>
@@ -3110,7 +3110,7 @@
         </p:nvSpPr>
         <p:spPr>
           <a:xfrm>
-            <a:off x="3364992" y="5029200"/>
+            <a:off x="3364992" y="5010912"/>
             <a:ext cx="2514600" cy="365760"/>
           </a:xfrm>
           <a:prstGeom prst="rect">
@@ -3127,7 +3127,7 @@
               <a:buNone/>
             </a:pPr>
             <a:r>
-              <a:rPr lang="en-US" sz="1250" dirty="0">
+              <a:rPr lang="en-US" sz="1200" dirty="0">
                 <a:solidFill>
                   <a:srgbClr val="9AA7B4"/>
                 </a:solidFill>
@@ -3135,9 +3135,9 @@
                 <a:ea typeface="Calibri" pitchFamily="34" charset="-122"/>
                 <a:cs typeface="Calibri" pitchFamily="34" charset="-120"/>
               </a:rPr>
-              <a:t>full run on Railway</a:t>
-            </a:r>
-            <a:endParaRPr lang="en-US" sz="1250" dirty="0"/>
+              <a:t>matching run on Railway</a:t>
+            </a:r>
+            <a:endParaRPr lang="en-US" sz="1200" dirty="0"/>
           </a:p>
         </p:txBody>
       </p:sp>
@@ -3176,8 +3176,8 @@
         </p:nvSpPr>
         <p:spPr>
           <a:xfrm>
-            <a:off x="6089904" y="4315968"/>
-            <a:ext cx="2514600" cy="640080"/>
+            <a:off x="6089904" y="4334256"/>
+            <a:ext cx="2514600" cy="594360"/>
           </a:xfrm>
           <a:prstGeom prst="rect">
             <a:avLst/>
@@ -3193,7 +3193,7 @@
               <a:buNone/>
             </a:pPr>
             <a:r>
-              <a:rPr lang="en-US" sz="3000" b="1" dirty="0">
+              <a:rPr lang="en-US" sz="2600" b="1" dirty="0">
                 <a:solidFill>
                   <a:srgbClr val="5EEAD4"/>
                 </a:solidFill>
@@ -3201,9 +3201,9 @@
                 <a:ea typeface="Georgia" pitchFamily="34" charset="-122"/>
                 <a:cs typeface="Georgia" pitchFamily="34" charset="-120"/>
               </a:rPr>
-              <a:t>14</a:t>
-            </a:r>
-            <a:endParaRPr lang="en-US" sz="3000" dirty="0"/>
+              <a:t>2,000+/day</a:t>
+            </a:r>
+            <a:endParaRPr lang="en-US" sz="2600" dirty="0"/>
           </a:p>
         </p:txBody>
       </p:sp>
@@ -3215,7 +3215,7 @@
         </p:nvSpPr>
         <p:spPr>
           <a:xfrm>
-            <a:off x="6089904" y="5029200"/>
+            <a:off x="6089904" y="5010912"/>
             <a:ext cx="2514600" cy="365760"/>
           </a:xfrm>
           <a:prstGeom prst="rect">
@@ -3232,7 +3232,7 @@
               <a:buNone/>
             </a:pPr>
             <a:r>
-              <a:rPr lang="en-US" sz="1250" dirty="0">
+              <a:rPr lang="en-US" sz="1200" dirty="0">
                 <a:solidFill>
                   <a:srgbClr val="9AA7B4"/>
                 </a:solidFill>
@@ -3240,9 +3240,9 @@
                 <a:ea typeface="Calibri" pitchFamily="34" charset="-122"/>
                 <a:cs typeface="Calibri" pitchFamily="34" charset="-120"/>
               </a:rPr>
-              <a:t>services on Railway</a:t>
-            </a:r>
-            <a:endParaRPr lang="en-US" sz="1250" dirty="0"/>
+              <a:t>WhatsApp + email</a:t>
+            </a:r>
+            <a:endParaRPr lang="en-US" sz="1200" dirty="0"/>
           </a:p>
         </p:txBody>
       </p:sp>
@@ -3281,8 +3281,8 @@
         </p:nvSpPr>
         <p:spPr>
           <a:xfrm>
-            <a:off x="8814816" y="4315968"/>
-            <a:ext cx="2514600" cy="640080"/>
+            <a:off x="8814816" y="4334256"/>
+            <a:ext cx="2514600" cy="594360"/>
           </a:xfrm>
           <a:prstGeom prst="rect">
             <a:avLst/>
@@ -3298,7 +3298,7 @@
               <a:buNone/>
             </a:pPr>
             <a:r>
-              <a:rPr lang="en-US" sz="3000" b="1" dirty="0">
+              <a:rPr lang="en-US" sz="2600" b="1" dirty="0">
                 <a:solidFill>
                   <a:srgbClr val="5EEAD4"/>
                 </a:solidFill>
@@ -3306,9 +3306,9 @@
                 <a:ea typeface="Georgia" pitchFamily="34" charset="-122"/>
                 <a:cs typeface="Georgia" pitchFamily="34" charset="-120"/>
               </a:rPr>
-              <a:t>weeks→hrs</a:t>
-            </a:r>
-            <a:endParaRPr lang="en-US" sz="3000" dirty="0"/>
+              <a:t>&lt;1 min</a:t>
+            </a:r>
+            <a:endParaRPr lang="en-US" sz="2600" dirty="0"/>
           </a:p>
         </p:txBody>
       </p:sp>
@@ -3320,7 +3320,7 @@
         </p:nvSpPr>
         <p:spPr>
           <a:xfrm>
-            <a:off x="8814816" y="5029200"/>
+            <a:off x="8814816" y="5010912"/>
             <a:ext cx="2514600" cy="365760"/>
           </a:xfrm>
           <a:prstGeom prst="rect">
@@ -3337,7 +3337,7 @@
               <a:buNone/>
             </a:pPr>
             <a:r>
-              <a:rPr lang="en-US" sz="1250" dirty="0">
+              <a:rPr lang="en-US" sz="1200" dirty="0">
                 <a:solidFill>
                   <a:srgbClr val="9AA7B4"/>
                 </a:solidFill>
@@ -3345,9 +3345,9 @@
                 <a:ea typeface="Calibri" pitchFamily="34" charset="-122"/>
                 <a:cs typeface="Calibri" pitchFamily="34" charset="-120"/>
               </a:rPr>
-              <a:t>screening per role</a:t>
-            </a:r>
-            <a:endParaRPr lang="en-US" sz="1250" dirty="0"/>
+              <a:t>CV parsed, regex-first</a:t>
+            </a:r>
+            <a:endParaRPr lang="en-US" sz="1200" dirty="0"/>
           </a:p>
         </p:txBody>
       </p:sp>
@@ -3384,7 +3384,7 @@
                 <a:ea typeface="Calibri" pitchFamily="34" charset="-122"/>
                 <a:cs typeface="Calibri" pitchFamily="34" charset="-120"/>
               </a:rPr>
-              <a:t>Deployed on Railway, triggered by webhooks, runs unattended.</a:t>
+              <a:t>Deployed on Railway, triggered by webhooks, runs unattended, with Slack status to the whole team.</a:t>
             </a:r>
             <a:endParaRPr lang="en-US" sz="1300" dirty="0"/>
           </a:p>
@@ -5606,7 +5606,7 @@
                 <a:ea typeface="Consolas" pitchFamily="34" charset="-122"/>
                 <a:cs typeface="Consolas" pitchFamily="34" charset="-120"/>
               </a:rPr>
-              <a:t>ENGINEERING</a:t>
+              <a:t>UNDER THE HOOD</a:t>
             </a:r>
             <a:endParaRPr lang="en-US" sz="1100" dirty="0"/>
           </a:p>
@@ -6451,7 +6451,7 @@
                 <a:ea typeface="Georgia" pitchFamily="34" charset="-122"/>
                 <a:cs typeface="Georgia" pitchFamily="34" charset="-120"/>
               </a:rPr>
-              <a:t>Cost control</a:t>
+              <a:t>AI only where needed</a:t>
             </a:r>
             <a:endParaRPr lang="en-US" sz="1500" dirty="0"/>
           </a:p>
@@ -6490,7 +6490,7 @@
                 <a:ea typeface="Calibri" pitchFamily="34" charset="-122"/>
                 <a:cs typeface="Calibri" pitchFamily="34" charset="-120"/>
               </a:rPr>
-              <a:t>Cheap filters first, candidate caps, TTL cache, minimal LLM spend.</a:t>
+              <a:t>DeepSeek for judgment; regex for parsing, filtering, routing. No wasted tokens.</a:t>
             </a:r>
             <a:endParaRPr lang="en-US" sz="1200" dirty="0"/>
           </a:p>
@@ -6620,7 +6620,7 @@
                 <a:ea typeface="Georgia" pitchFamily="34" charset="-122"/>
                 <a:cs typeface="Georgia" pitchFamily="34" charset="-120"/>
               </a:rPr>
-              <a:t>Observability</a:t>
+              <a:t>Observability + Slack</a:t>
             </a:r>
             <a:endParaRPr lang="en-US" sz="1500" dirty="0"/>
           </a:p>
@@ -6659,7 +6659,7 @@
                 <a:ea typeface="Calibri" pitchFamily="34" charset="-122"/>
                 <a:cs typeface="Calibri" pitchFamily="34" charset="-120"/>
               </a:rPr>
-              <a:t>Logs keyed by id, email, stage, skip reason, debuggable from logs alone.</a:t>
+              <a:t>Logs keyed by id, email, stage; Slack status to the team at start and finish.</a:t>
             </a:r>
             <a:endParaRPr lang="en-US" sz="1200" dirty="0"/>
           </a:p>
@@ -7638,7 +7638,7 @@
                 <a:ea typeface="Calibri" pitchFamily="34" charset="-122"/>
                 <a:cs typeface="Calibri" pitchFamily="34" charset="-120"/>
               </a:rPr>
-              <a:t>candidate rows scanned per run, unattended</a:t>
+              <a:t>candidate rows scanned per matching run</a:t>
             </a:r>
             <a:endParaRPr lang="en-US" sz="1400" dirty="0"/>
           </a:p>
@@ -7704,7 +7704,7 @@
                 <a:ea typeface="Georgia" pitchFamily="34" charset="-122"/>
                 <a:cs typeface="Georgia" pitchFamily="34" charset="-120"/>
               </a:rPr>
-              <a:t>~2 hrs</a:t>
+              <a:t>90-120 min</a:t>
             </a:r>
             <a:endParaRPr lang="en-US" sz="3800" dirty="0"/>
           </a:p>
@@ -7743,7 +7743,7 @@
                 <a:ea typeface="Calibri" pitchFamily="34" charset="-122"/>
                 <a:cs typeface="Calibri" pitchFamily="34" charset="-120"/>
               </a:rPr>
-              <a:t>full run on Railway, webhook to shortlist</a:t>
+              <a:t>full run on Railway, with Slack status</a:t>
             </a:r>
             <a:endParaRPr lang="en-US" sz="1400" dirty="0"/>
           </a:p>
@@ -7809,7 +7809,7 @@
                 <a:ea typeface="Georgia" pitchFamily="34" charset="-122"/>
                 <a:cs typeface="Georgia" pitchFamily="34" charset="-120"/>
               </a:rPr>
-              <a:t>weeks→hrs</a:t>
+              <a:t>2,000+/day</a:t>
             </a:r>
             <a:endParaRPr lang="en-US" sz="3800" dirty="0"/>
           </a:p>
@@ -7848,7 +7848,7 @@
                 <a:ea typeface="Calibri" pitchFamily="34" charset="-122"/>
                 <a:cs typeface="Calibri" pitchFamily="34" charset="-120"/>
               </a:rPr>
-              <a:t>recruiter screening per role, collapsed</a:t>
+              <a:t>WhatsApp + emails (Twilio + Postmark)</a:t>
             </a:r>
             <a:endParaRPr lang="en-US" sz="1400" dirty="0"/>
           </a:p>
@@ -7914,7 +7914,7 @@
                 <a:ea typeface="Georgia" pitchFamily="34" charset="-122"/>
                 <a:cs typeface="Georgia" pitchFamily="34" charset="-120"/>
               </a:rPr>
-              <a:t>1</a:t>
+              <a:t>&lt;1 min</a:t>
             </a:r>
             <a:endParaRPr lang="en-US" sz="3800" dirty="0"/>
           </a:p>
@@ -7953,7 +7953,7 @@
                 <a:ea typeface="Calibri" pitchFamily="34" charset="-122"/>
                 <a:cs typeface="Calibri" pitchFamily="34" charset="-120"/>
               </a:rPr>
-              <a:t>written rationale on every single match</a:t>
+              <a:t>to parse a CV, regex-first, AI only when needed</a:t>
             </a:r>
             <a:endParaRPr lang="en-US" sz="1400" dirty="0"/>
           </a:p>
@@ -7992,7 +7992,7 @@
                 <a:ea typeface="Calibri" pitchFamily="34" charset="-122"/>
                 <a:cs typeface="Calibri" pitchFamily="34" charset="-120"/>
               </a:rPr>
-              <a:t>Business outcome above. The six-stage workflow that produces it is on the previous slides.</a:t>
+              <a:t>Manual work that took weeks, now seconds to a couple of hours. Workflow on the previous slides.</a:t>
             </a:r>
             <a:endParaRPr lang="en-US" sz="1300" dirty="0"/>
           </a:p>
@@ -8124,7 +8124,7 @@
                 <a:ea typeface="Georgia" pitchFamily="34" charset="-122"/>
                 <a:cs typeface="Georgia" pitchFamily="34" charset="-120"/>
               </a:rPr>
-              <a:t>Automation</a:t>
+              <a:t>AI automation</a:t>
             </a:r>
             <a:endParaRPr lang="en-US" sz="2100" dirty="0"/>
           </a:p>
@@ -8324,7 +8324,7 @@
                 <a:ea typeface="Georgia" pitchFamily="34" charset="-122"/>
                 <a:cs typeface="Georgia" pitchFamily="34" charset="-120"/>
               </a:rPr>
-              <a:t>Applied AI</a:t>
+              <a:t>Cost-aware AI</a:t>
             </a:r>
             <a:endParaRPr lang="en-US" sz="2100" dirty="0"/>
           </a:p>
@@ -8363,7 +8363,7 @@
                 <a:ea typeface="Calibri" pitchFamily="34" charset="-122"/>
                 <a:cs typeface="Calibri" pitchFamily="34" charset="-120"/>
               </a:rPr>
-              <a:t>A cost-aware, explainable, retried LLM scoring pipeline, not a single API call.</a:t>
+              <a:t>DeepSeek on judgment-heavy steps, regex everywhere else. No wasted tokens.</a:t>
             </a:r>
             <a:endParaRPr lang="en-US" sz="1500" dirty="0"/>
           </a:p>

</xml_diff>